<commit_message>
Deck: replace the latency-rationale slide with the measured ranking inversion
The slide previously made the sparse/bulk argument with fq_codel's own
two numbers. The measured data gives a far stronger case: the
probe-to-bulk ratio ranges from 1.1x (CoDel) to 9.6x (SFQ), and by
probe RTT alone SFQ (30.7 ms) appears to beat CoDel (39.2 ms) while on
bulk RTT it is 294 ms against 44 ms. SFQ gives the probe its own short
queue but has no AQM, so its bulk queues sit at the 127-packet limit.

Co-Authored-By: Claude Opus 5 <noreply@anthropic.com>
Claude-Session: https://claude.ai/code/session_01UaJoj4S6rdXLuhz6cKL5GK
</commit_message>
<xml_diff>
--- a/deck/ACAPE_2026.pptx
+++ b/deck/ACAPE_2026.pptx
@@ -1574,7 +1574,7 @@
           <a:p>
             <a:r>
               <a:rPr lang="en-US" dirty="0"/>
-              <a:t>We also raised the probe rate from 5 Hz to 20 Hz so the p99 is stable.</a:t>
+              <a:t>The probe-to-bulk ratio is a discipline signature. Any AQM paper quoting a single ping number may be ranking systems backwards.</a:t>
             </a:r>
             <a:endParaRPr lang="en-US" dirty="0"/>
           </a:p>
@@ -9321,8 +9321,8 @@
         </p:nvSpPr>
         <p:spPr>
           <a:xfrm>
-            <a:off x="640080" y="1097280"/>
-            <a:ext cx="10881360" cy="365760"/>
+            <a:off x="640080" y="1051560"/>
+            <a:ext cx="10881360" cy="347472"/>
           </a:xfrm>
           <a:prstGeom prst="rect">
             <a:avLst/>
@@ -9360,8 +9360,8 @@
         </p:nvSpPr>
         <p:spPr>
           <a:xfrm>
-            <a:off x="640080" y="1554480"/>
-            <a:ext cx="10881360" cy="548640"/>
+            <a:off x="640080" y="1444752"/>
+            <a:ext cx="10881360" cy="457200"/>
           </a:xfrm>
           <a:prstGeom prst="rect">
             <a:avLst/>
@@ -9377,7 +9377,7 @@
               <a:buNone/>
             </a:pPr>
             <a:r>
-              <a:rPr lang="en-US" sz="1500" dirty="0">
+              <a:rPr lang="en-US" sz="1450" dirty="0">
                 <a:solidFill>
                   <a:srgbClr val="3A4A5F"/>
                 </a:solidFill>
@@ -9385,72 +9385,587 @@
                 <a:ea typeface="Calibri" pitchFamily="34" charset="-122"/>
                 <a:cs typeface="Calibri" pitchFamily="34" charset="-120"/>
               </a:rPr>
-              <a:t>fq_codel's new-flow heuristic deliberately privileges sparse flows. A ping is a sparse flow. So a ping measures the best case, not what the bulk traffic sees.</a:t>
-            </a:r>
-            <a:endParaRPr lang="en-US" sz="1500" dirty="0"/>
-          </a:p>
-        </p:txBody>
-      </p:sp>
-      <p:sp>
-        <p:nvSpPr>
-          <p:cNvPr id="5" name="Shape 3"/>
+              <a:t>fq_codel's new-flow heuristic deliberately privileges sparse flows. A ping is a sparse flow, so it measures the best case — not what the bulk traffic sees.</a:t>
+            </a:r>
+            <a:endParaRPr lang="en-US" sz="1450" dirty="0"/>
+          </a:p>
+        </p:txBody>
+      </p:sp>
+      <p:sp>
+        <p:nvSpPr>
+          <p:cNvPr id="5" name="Text 3"/>
+          <p:cNvSpPr txBox="1"/>
+          <p:nvPr/>
+        </p:nvSpPr>
+        <p:spPr>
+          <a:xfrm>
+            <a:off x="914400" y="1993392"/>
+            <a:ext cx="2103120" cy="274320"/>
+          </a:xfrm>
+          <a:prstGeom prst="rect">
+            <a:avLst/>
+          </a:prstGeom>
+          <a:noFill/>
+          <a:ln/>
+        </p:spPr>
+        <p:txBody>
+          <a:bodyPr wrap="square" lIns="0" tIns="0" rIns="0" bIns="0" rtlCol="0" anchor="ctr"/>
+          <a:lstStyle/>
+          <a:p>
+            <a:pPr indent="0" marL="0">
+              <a:buNone/>
+            </a:pPr>
+            <a:r>
+              <a:rPr lang="en-US" sz="1150" b="1" spc="100" kern="0" dirty="0">
+                <a:solidFill>
+                  <a:srgbClr val="7B8A9C"/>
+                </a:solidFill>
+                <a:latin typeface="Calibri" pitchFamily="34" charset="0"/>
+                <a:ea typeface="Calibri" pitchFamily="34" charset="-122"/>
+                <a:cs typeface="Calibri" pitchFamily="34" charset="-120"/>
+              </a:rPr>
+              <a:t>Discipline</a:t>
+            </a:r>
+            <a:endParaRPr lang="en-US" sz="1150" dirty="0"/>
+          </a:p>
+        </p:txBody>
+      </p:sp>
+      <p:sp>
+        <p:nvSpPr>
+          <p:cNvPr id="6" name="Text 4"/>
+          <p:cNvSpPr txBox="1"/>
+          <p:nvPr/>
+        </p:nvSpPr>
+        <p:spPr>
+          <a:xfrm>
+            <a:off x="5486400" y="1993392"/>
+            <a:ext cx="2103120" cy="274320"/>
+          </a:xfrm>
+          <a:prstGeom prst="rect">
+            <a:avLst/>
+          </a:prstGeom>
+          <a:noFill/>
+          <a:ln/>
+        </p:spPr>
+        <p:txBody>
+          <a:bodyPr wrap="square" lIns="0" tIns="0" rIns="0" bIns="0" rtlCol="0" anchor="ctr"/>
+          <a:lstStyle/>
+          <a:p>
+            <a:pPr indent="0" marL="0">
+              <a:buNone/>
+            </a:pPr>
+            <a:r>
+              <a:rPr lang="en-US" sz="1150" b="1" spc="100" kern="0" dirty="0">
+                <a:solidFill>
+                  <a:srgbClr val="7B8A9C"/>
+                </a:solidFill>
+                <a:latin typeface="Calibri" pitchFamily="34" charset="0"/>
+                <a:ea typeface="Calibri" pitchFamily="34" charset="-122"/>
+                <a:cs typeface="Calibri" pitchFamily="34" charset="-120"/>
+              </a:rPr>
+              <a:t>Sparse probe</a:t>
+            </a:r>
+            <a:endParaRPr lang="en-US" sz="1150" dirty="0"/>
+          </a:p>
+        </p:txBody>
+      </p:sp>
+      <p:sp>
+        <p:nvSpPr>
+          <p:cNvPr id="7" name="Text 5"/>
+          <p:cNvSpPr txBox="1"/>
+          <p:nvPr/>
+        </p:nvSpPr>
+        <p:spPr>
+          <a:xfrm>
+            <a:off x="7498080" y="1993392"/>
+            <a:ext cx="2103120" cy="274320"/>
+          </a:xfrm>
+          <a:prstGeom prst="rect">
+            <a:avLst/>
+          </a:prstGeom>
+          <a:noFill/>
+          <a:ln/>
+        </p:spPr>
+        <p:txBody>
+          <a:bodyPr wrap="square" lIns="0" tIns="0" rIns="0" bIns="0" rtlCol="0" anchor="ctr"/>
+          <a:lstStyle/>
+          <a:p>
+            <a:pPr indent="0" marL="0">
+              <a:buNone/>
+            </a:pPr>
+            <a:r>
+              <a:rPr lang="en-US" sz="1150" b="1" spc="100" kern="0" dirty="0">
+                <a:solidFill>
+                  <a:srgbClr val="7B8A9C"/>
+                </a:solidFill>
+                <a:latin typeface="Calibri" pitchFamily="34" charset="0"/>
+                <a:ea typeface="Calibri" pitchFamily="34" charset="-122"/>
+                <a:cs typeface="Calibri" pitchFamily="34" charset="-120"/>
+              </a:rPr>
+              <a:t>Bulk flows</a:t>
+            </a:r>
+            <a:endParaRPr lang="en-US" sz="1150" dirty="0"/>
+          </a:p>
+        </p:txBody>
+      </p:sp>
+      <p:sp>
+        <p:nvSpPr>
+          <p:cNvPr id="8" name="Text 6"/>
+          <p:cNvSpPr txBox="1"/>
+          <p:nvPr/>
+        </p:nvSpPr>
+        <p:spPr>
+          <a:xfrm>
+            <a:off x="9601200" y="1993392"/>
+            <a:ext cx="2103120" cy="274320"/>
+          </a:xfrm>
+          <a:prstGeom prst="rect">
+            <a:avLst/>
+          </a:prstGeom>
+          <a:noFill/>
+          <a:ln/>
+        </p:spPr>
+        <p:txBody>
+          <a:bodyPr wrap="square" lIns="0" tIns="0" rIns="0" bIns="0" rtlCol="0" anchor="ctr"/>
+          <a:lstStyle/>
+          <a:p>
+            <a:pPr indent="0" marL="0">
+              <a:buNone/>
+            </a:pPr>
+            <a:r>
+              <a:rPr lang="en-US" sz="1150" b="1" spc="100" kern="0" dirty="0">
+                <a:solidFill>
+                  <a:srgbClr val="7B8A9C"/>
+                </a:solidFill>
+                <a:latin typeface="Calibri" pitchFamily="34" charset="0"/>
+                <a:ea typeface="Calibri" pitchFamily="34" charset="-122"/>
+                <a:cs typeface="Calibri" pitchFamily="34" charset="-120"/>
+              </a:rPr>
+              <a:t>Ratio</a:t>
+            </a:r>
+            <a:endParaRPr lang="en-US" sz="1150" dirty="0"/>
+          </a:p>
+        </p:txBody>
+      </p:sp>
+      <p:sp>
+        <p:nvSpPr>
+          <p:cNvPr id="9" name="Shape 7"/>
           <p:cNvSpPr/>
           <p:nvPr/>
         </p:nvSpPr>
         <p:spPr>
           <a:xfrm>
-            <a:off x="640080" y="2331720"/>
-            <a:ext cx="10881360" cy="960120"/>
+            <a:off x="640080" y="2304288"/>
+            <a:ext cx="10881360" cy="475488"/>
           </a:xfrm>
           <a:prstGeom prst="roundRect">
             <a:avLst>
-              <a:gd name="adj" fmla="val 7619"/>
+              <a:gd name="adj" fmla="val 9615"/>
+            </a:avLst>
+          </a:prstGeom>
+          <a:solidFill>
+            <a:srgbClr val="FBEEF0"/>
+          </a:solidFill>
+          <a:ln w="6350">
+            <a:solidFill>
+              <a:srgbClr val="E2ECF2"/>
+            </a:solidFill>
+            <a:prstDash val="solid"/>
+          </a:ln>
+        </p:spPr>
+      </p:sp>
+      <p:sp>
+        <p:nvSpPr>
+          <p:cNvPr id="10" name="Text 8"/>
+          <p:cNvSpPr txBox="1"/>
+          <p:nvPr/>
+        </p:nvSpPr>
+        <p:spPr>
+          <a:xfrm>
+            <a:off x="914400" y="2404872"/>
+            <a:ext cx="4480560" cy="292608"/>
+          </a:xfrm>
+          <a:prstGeom prst="rect">
+            <a:avLst/>
+          </a:prstGeom>
+          <a:noFill/>
+          <a:ln/>
+        </p:spPr>
+        <p:txBody>
+          <a:bodyPr wrap="square" lIns="0" tIns="0" rIns="0" bIns="0" rtlCol="0" anchor="ctr"/>
+          <a:lstStyle/>
+          <a:p>
+            <a:pPr indent="0" marL="0">
+              <a:buNone/>
+            </a:pPr>
+            <a:r>
+              <a:rPr lang="en-US" sz="1300" b="1" dirty="0">
+                <a:solidFill>
+                  <a:srgbClr val="13233B"/>
+                </a:solidFill>
+                <a:latin typeface="Calibri" pitchFamily="34" charset="0"/>
+                <a:ea typeface="Calibri" pitchFamily="34" charset="-122"/>
+                <a:cs typeface="Calibri" pitchFamily="34" charset="-120"/>
+              </a:rPr>
+              <a:t>SFQ  (fair queueing, no AQM)</a:t>
+            </a:r>
+            <a:endParaRPr lang="en-US" sz="1300" dirty="0"/>
+          </a:p>
+        </p:txBody>
+      </p:sp>
+      <p:sp>
+        <p:nvSpPr>
+          <p:cNvPr id="11" name="Text 9"/>
+          <p:cNvSpPr txBox="1"/>
+          <p:nvPr/>
+        </p:nvSpPr>
+        <p:spPr>
+          <a:xfrm>
+            <a:off x="5486400" y="2386584"/>
+            <a:ext cx="1828800" cy="329184"/>
+          </a:xfrm>
+          <a:prstGeom prst="rect">
+            <a:avLst/>
+          </a:prstGeom>
+          <a:noFill/>
+          <a:ln/>
+        </p:spPr>
+        <p:txBody>
+          <a:bodyPr wrap="square" lIns="0" tIns="0" rIns="0" bIns="0" rtlCol="0" anchor="ctr"/>
+          <a:lstStyle/>
+          <a:p>
+            <a:pPr indent="0" marL="0">
+              <a:buNone/>
+            </a:pPr>
+            <a:r>
+              <a:rPr lang="en-US" sz="1400" dirty="0">
+                <a:solidFill>
+                  <a:srgbClr val="1C7293"/>
+                </a:solidFill>
+                <a:latin typeface="Cambria" pitchFamily="34" charset="0"/>
+                <a:ea typeface="Cambria" pitchFamily="34" charset="-122"/>
+                <a:cs typeface="Cambria" pitchFamily="34" charset="-120"/>
+              </a:rPr>
+              <a:t>30.7 ms</a:t>
+            </a:r>
+            <a:endParaRPr lang="en-US" sz="1400" dirty="0"/>
+          </a:p>
+        </p:txBody>
+      </p:sp>
+      <p:sp>
+        <p:nvSpPr>
+          <p:cNvPr id="12" name="Text 10"/>
+          <p:cNvSpPr txBox="1"/>
+          <p:nvPr/>
+        </p:nvSpPr>
+        <p:spPr>
+          <a:xfrm>
+            <a:off x="7498080" y="2386584"/>
+            <a:ext cx="1828800" cy="329184"/>
+          </a:xfrm>
+          <a:prstGeom prst="rect">
+            <a:avLst/>
+          </a:prstGeom>
+          <a:noFill/>
+          <a:ln/>
+        </p:spPr>
+        <p:txBody>
+          <a:bodyPr wrap="square" lIns="0" tIns="0" rIns="0" bIns="0" rtlCol="0" anchor="ctr"/>
+          <a:lstStyle/>
+          <a:p>
+            <a:pPr indent="0" marL="0">
+              <a:buNone/>
+            </a:pPr>
+            <a:r>
+              <a:rPr lang="en-US" sz="1400" b="1" dirty="0">
+                <a:solidFill>
+                  <a:srgbClr val="B23A48"/>
+                </a:solidFill>
+                <a:latin typeface="Cambria" pitchFamily="34" charset="0"/>
+                <a:ea typeface="Cambria" pitchFamily="34" charset="-122"/>
+                <a:cs typeface="Cambria" pitchFamily="34" charset="-120"/>
+              </a:rPr>
+              <a:t>294.3 ms</a:t>
+            </a:r>
+            <a:endParaRPr lang="en-US" sz="1400" dirty="0"/>
+          </a:p>
+        </p:txBody>
+      </p:sp>
+      <p:sp>
+        <p:nvSpPr>
+          <p:cNvPr id="13" name="Text 11"/>
+          <p:cNvSpPr txBox="1"/>
+          <p:nvPr/>
+        </p:nvSpPr>
+        <p:spPr>
+          <a:xfrm>
+            <a:off x="9601200" y="2404872"/>
+            <a:ext cx="1463040" cy="292608"/>
+          </a:xfrm>
+          <a:prstGeom prst="rect">
+            <a:avLst/>
+          </a:prstGeom>
+          <a:noFill/>
+          <a:ln/>
+        </p:spPr>
+        <p:txBody>
+          <a:bodyPr wrap="square" lIns="0" tIns="0" rIns="0" bIns="0" rtlCol="0" anchor="ctr"/>
+          <a:lstStyle/>
+          <a:p>
+            <a:pPr indent="0" marL="0">
+              <a:buNone/>
+            </a:pPr>
+            <a:r>
+              <a:rPr lang="en-US" sz="1300" b="1" dirty="0">
+                <a:solidFill>
+                  <a:srgbClr val="B23A48"/>
+                </a:solidFill>
+                <a:latin typeface="Calibri" pitchFamily="34" charset="0"/>
+                <a:ea typeface="Calibri" pitchFamily="34" charset="-122"/>
+                <a:cs typeface="Calibri" pitchFamily="34" charset="-120"/>
+              </a:rPr>
+              <a:t>9.6x</a:t>
+            </a:r>
+            <a:endParaRPr lang="en-US" sz="1300" dirty="0"/>
+          </a:p>
+        </p:txBody>
+      </p:sp>
+      <p:sp>
+        <p:nvSpPr>
+          <p:cNvPr id="14" name="Shape 12"/>
+          <p:cNvSpPr/>
+          <p:nvPr/>
+        </p:nvSpPr>
+        <p:spPr>
+          <a:xfrm>
+            <a:off x="640080" y="2852928"/>
+            <a:ext cx="10881360" cy="475488"/>
+          </a:xfrm>
+          <a:prstGeom prst="roundRect">
+            <a:avLst>
+              <a:gd name="adj" fmla="val 9615"/>
+            </a:avLst>
+          </a:prstGeom>
+          <a:solidFill>
+            <a:srgbClr val="F6FAFC"/>
+          </a:solidFill>
+          <a:ln w="6350">
+            <a:solidFill>
+              <a:srgbClr val="E2ECF2"/>
+            </a:solidFill>
+            <a:prstDash val="solid"/>
+          </a:ln>
+        </p:spPr>
+      </p:sp>
+      <p:sp>
+        <p:nvSpPr>
+          <p:cNvPr id="15" name="Text 13"/>
+          <p:cNvSpPr txBox="1"/>
+          <p:nvPr/>
+        </p:nvSpPr>
+        <p:spPr>
+          <a:xfrm>
+            <a:off x="914400" y="2953512"/>
+            <a:ext cx="4480560" cy="292608"/>
+          </a:xfrm>
+          <a:prstGeom prst="rect">
+            <a:avLst/>
+          </a:prstGeom>
+          <a:noFill/>
+          <a:ln/>
+        </p:spPr>
+        <p:txBody>
+          <a:bodyPr wrap="square" lIns="0" tIns="0" rIns="0" bIns="0" rtlCol="0" anchor="ctr"/>
+          <a:lstStyle/>
+          <a:p>
+            <a:pPr indent="0" marL="0">
+              <a:buNone/>
+            </a:pPr>
+            <a:r>
+              <a:rPr lang="en-US" sz="1300" dirty="0">
+                <a:solidFill>
+                  <a:srgbClr val="13233B"/>
+                </a:solidFill>
+                <a:latin typeface="Calibri" pitchFamily="34" charset="0"/>
+                <a:ea typeface="Calibri" pitchFamily="34" charset="-122"/>
+                <a:cs typeface="Calibri" pitchFamily="34" charset="-120"/>
+              </a:rPr>
+              <a:t>FQ-PIE</a:t>
+            </a:r>
+            <a:endParaRPr lang="en-US" sz="1300" dirty="0"/>
+          </a:p>
+        </p:txBody>
+      </p:sp>
+      <p:sp>
+        <p:nvSpPr>
+          <p:cNvPr id="16" name="Text 14"/>
+          <p:cNvSpPr txBox="1"/>
+          <p:nvPr/>
+        </p:nvSpPr>
+        <p:spPr>
+          <a:xfrm>
+            <a:off x="5486400" y="2935224"/>
+            <a:ext cx="1828800" cy="329184"/>
+          </a:xfrm>
+          <a:prstGeom prst="rect">
+            <a:avLst/>
+          </a:prstGeom>
+          <a:noFill/>
+          <a:ln/>
+        </p:spPr>
+        <p:txBody>
+          <a:bodyPr wrap="square" lIns="0" tIns="0" rIns="0" bIns="0" rtlCol="0" anchor="ctr"/>
+          <a:lstStyle/>
+          <a:p>
+            <a:pPr indent="0" marL="0">
+              <a:buNone/>
+            </a:pPr>
+            <a:r>
+              <a:rPr lang="en-US" sz="1400" dirty="0">
+                <a:solidFill>
+                  <a:srgbClr val="1C7293"/>
+                </a:solidFill>
+                <a:latin typeface="Cambria" pitchFamily="34" charset="0"/>
+                <a:ea typeface="Cambria" pitchFamily="34" charset="-122"/>
+                <a:cs typeface="Cambria" pitchFamily="34" charset="-120"/>
+              </a:rPr>
+              <a:t>22.0 ms</a:t>
+            </a:r>
+            <a:endParaRPr lang="en-US" sz="1400" dirty="0"/>
+          </a:p>
+        </p:txBody>
+      </p:sp>
+      <p:sp>
+        <p:nvSpPr>
+          <p:cNvPr id="17" name="Text 15"/>
+          <p:cNvSpPr txBox="1"/>
+          <p:nvPr/>
+        </p:nvSpPr>
+        <p:spPr>
+          <a:xfrm>
+            <a:off x="7498080" y="2935224"/>
+            <a:ext cx="1828800" cy="329184"/>
+          </a:xfrm>
+          <a:prstGeom prst="rect">
+            <a:avLst/>
+          </a:prstGeom>
+          <a:noFill/>
+          <a:ln/>
+        </p:spPr>
+        <p:txBody>
+          <a:bodyPr wrap="square" lIns="0" tIns="0" rIns="0" bIns="0" rtlCol="0" anchor="ctr"/>
+          <a:lstStyle/>
+          <a:p>
+            <a:pPr indent="0" marL="0">
+              <a:buNone/>
+            </a:pPr>
+            <a:r>
+              <a:rPr lang="en-US" sz="1400" b="1" dirty="0">
+                <a:solidFill>
+                  <a:srgbClr val="3A4A5F"/>
+                </a:solidFill>
+                <a:latin typeface="Cambria" pitchFamily="34" charset="0"/>
+                <a:ea typeface="Cambria" pitchFamily="34" charset="-122"/>
+                <a:cs typeface="Cambria" pitchFamily="34" charset="-120"/>
+              </a:rPr>
+              <a:t>55.2 ms</a:t>
+            </a:r>
+            <a:endParaRPr lang="en-US" sz="1400" dirty="0"/>
+          </a:p>
+        </p:txBody>
+      </p:sp>
+      <p:sp>
+        <p:nvSpPr>
+          <p:cNvPr id="18" name="Text 16"/>
+          <p:cNvSpPr txBox="1"/>
+          <p:nvPr/>
+        </p:nvSpPr>
+        <p:spPr>
+          <a:xfrm>
+            <a:off x="9601200" y="2953512"/>
+            <a:ext cx="1463040" cy="292608"/>
+          </a:xfrm>
+          <a:prstGeom prst="rect">
+            <a:avLst/>
+          </a:prstGeom>
+          <a:noFill/>
+          <a:ln/>
+        </p:spPr>
+        <p:txBody>
+          <a:bodyPr wrap="square" lIns="0" tIns="0" rIns="0" bIns="0" rtlCol="0" anchor="ctr"/>
+          <a:lstStyle/>
+          <a:p>
+            <a:pPr indent="0" marL="0">
+              <a:buNone/>
+            </a:pPr>
+            <a:r>
+              <a:rPr lang="en-US" sz="1300" b="1" dirty="0">
+                <a:solidFill>
+                  <a:srgbClr val="3A4A5F"/>
+                </a:solidFill>
+                <a:latin typeface="Calibri" pitchFamily="34" charset="0"/>
+                <a:ea typeface="Calibri" pitchFamily="34" charset="-122"/>
+                <a:cs typeface="Calibri" pitchFamily="34" charset="-120"/>
+              </a:rPr>
+              <a:t>2.5x</a:t>
+            </a:r>
+            <a:endParaRPr lang="en-US" sz="1300" dirty="0"/>
+          </a:p>
+        </p:txBody>
+      </p:sp>
+      <p:sp>
+        <p:nvSpPr>
+          <p:cNvPr id="19" name="Shape 17"/>
+          <p:cNvSpPr/>
+          <p:nvPr/>
+        </p:nvSpPr>
+        <p:spPr>
+          <a:xfrm>
+            <a:off x="640080" y="3401568"/>
+            <a:ext cx="10881360" cy="475488"/>
+          </a:xfrm>
+          <a:prstGeom prst="roundRect">
+            <a:avLst>
+              <a:gd name="adj" fmla="val 9615"/>
             </a:avLst>
           </a:prstGeom>
           <a:solidFill>
             <a:srgbClr val="EEF4F8"/>
           </a:solidFill>
-          <a:ln w="9525">
+          <a:ln w="6350">
             <a:solidFill>
-              <a:srgbClr val="D8E4EC"/>
+              <a:srgbClr val="E2ECF2"/>
             </a:solidFill>
             <a:prstDash val="solid"/>
           </a:ln>
-          <a:effectLst>
-            <a:outerShdw sx="100000" sy="100000" kx="0" ky="0" algn="bl" rotWithShape="0" blurRad="50800" dist="12700" dir="5400000">
-              <a:srgbClr val="BFCEDA">
-                <a:alpha val="35000"/>
-              </a:srgbClr>
-            </a:outerShdw>
-          </a:effectLst>
-        </p:spPr>
-      </p:sp>
-      <p:sp>
-        <p:nvSpPr>
-          <p:cNvPr id="6" name="Text 4"/>
-          <p:cNvSpPr txBox="1"/>
-          <p:nvPr/>
-        </p:nvSpPr>
-        <p:spPr>
-          <a:xfrm>
-            <a:off x="960120" y="2441448"/>
-            <a:ext cx="3291840" cy="365760"/>
-          </a:xfrm>
-          <a:prstGeom prst="rect">
-            <a:avLst/>
-          </a:prstGeom>
-          <a:noFill/>
-          <a:ln/>
-        </p:spPr>
-        <p:txBody>
-          <a:bodyPr wrap="square" lIns="0" tIns="0" rIns="0" bIns="0" rtlCol="0" anchor="ctr"/>
-          <a:lstStyle/>
-          <a:p>
-            <a:pPr indent="0" marL="0">
-              <a:buNone/>
-            </a:pPr>
-            <a:r>
-              <a:rPr lang="en-US" sz="1500" b="1" dirty="0">
+        </p:spPr>
+      </p:sp>
+      <p:sp>
+        <p:nvSpPr>
+          <p:cNvPr id="20" name="Text 18"/>
+          <p:cNvSpPr txBox="1"/>
+          <p:nvPr/>
+        </p:nvSpPr>
+        <p:spPr>
+          <a:xfrm>
+            <a:off x="914400" y="3502152"/>
+            <a:ext cx="4480560" cy="292608"/>
+          </a:xfrm>
+          <a:prstGeom prst="rect">
+            <a:avLst/>
+          </a:prstGeom>
+          <a:noFill/>
+          <a:ln/>
+        </p:spPr>
+        <p:txBody>
+          <a:bodyPr wrap="square" lIns="0" tIns="0" rIns="0" bIns="0" rtlCol="0" anchor="ctr"/>
+          <a:lstStyle/>
+          <a:p>
+            <a:pPr indent="0" marL="0">
+              <a:buNone/>
+            </a:pPr>
+            <a:r>
+              <a:rPr lang="en-US" sz="1300" dirty="0">
                 <a:solidFill>
                   <a:srgbClr val="13233B"/>
                 </a:solidFill>
@@ -9458,38 +9973,38 @@
                 <a:ea typeface="Calibri" pitchFamily="34" charset="-122"/>
                 <a:cs typeface="Calibri" pitchFamily="34" charset="-120"/>
               </a:rPr>
-              <a:t>Sparse ICMP probe</a:t>
-            </a:r>
-            <a:endParaRPr lang="en-US" sz="1500" dirty="0"/>
-          </a:p>
-        </p:txBody>
-      </p:sp>
-      <p:sp>
-        <p:nvSpPr>
-          <p:cNvPr id="7" name="Text 5"/>
-          <p:cNvSpPr txBox="1"/>
-          <p:nvPr/>
-        </p:nvSpPr>
-        <p:spPr>
-          <a:xfrm>
-            <a:off x="4389120" y="2423160"/>
-            <a:ext cx="1828800" cy="548640"/>
-          </a:xfrm>
-          <a:prstGeom prst="rect">
-            <a:avLst/>
-          </a:prstGeom>
-          <a:noFill/>
-          <a:ln/>
-        </p:spPr>
-        <p:txBody>
-          <a:bodyPr wrap="square" lIns="0" tIns="0" rIns="0" bIns="0" rtlCol="0" anchor="ctr"/>
-          <a:lstStyle/>
-          <a:p>
-            <a:pPr indent="0" marL="0">
-              <a:buNone/>
-            </a:pPr>
-            <a:r>
-              <a:rPr lang="en-US" sz="2800" b="1" dirty="0">
+              <a:t>fq_codel</a:t>
+            </a:r>
+            <a:endParaRPr lang="en-US" sz="1300" dirty="0"/>
+          </a:p>
+        </p:txBody>
+      </p:sp>
+      <p:sp>
+        <p:nvSpPr>
+          <p:cNvPr id="21" name="Text 19"/>
+          <p:cNvSpPr txBox="1"/>
+          <p:nvPr/>
+        </p:nvSpPr>
+        <p:spPr>
+          <a:xfrm>
+            <a:off x="5486400" y="3483864"/>
+            <a:ext cx="1828800" cy="329184"/>
+          </a:xfrm>
+          <a:prstGeom prst="rect">
+            <a:avLst/>
+          </a:prstGeom>
+          <a:noFill/>
+          <a:ln/>
+        </p:spPr>
+        <p:txBody>
+          <a:bodyPr wrap="square" lIns="0" tIns="0" rIns="0" bIns="0" rtlCol="0" anchor="ctr"/>
+          <a:lstStyle/>
+          <a:p>
+            <a:pPr indent="0" marL="0">
+              <a:buNone/>
+            </a:pPr>
+            <a:r>
+              <a:rPr lang="en-US" sz="1400" dirty="0">
                 <a:solidFill>
                   <a:srgbClr val="1C7293"/>
                 </a:solidFill>
@@ -9499,44 +10014,83 @@
               </a:rPr>
               <a:t>22.4 ms</a:t>
             </a:r>
-            <a:endParaRPr lang="en-US" sz="2800" dirty="0"/>
-          </a:p>
-        </p:txBody>
-      </p:sp>
-      <p:sp>
-        <p:nvSpPr>
-          <p:cNvPr id="8" name="Text 6"/>
-          <p:cNvSpPr txBox="1"/>
-          <p:nvPr/>
-        </p:nvSpPr>
-        <p:spPr>
-          <a:xfrm>
-            <a:off x="6400800" y="2560320"/>
-            <a:ext cx="4754880" cy="365760"/>
-          </a:xfrm>
-          <a:prstGeom prst="rect">
-            <a:avLst/>
-          </a:prstGeom>
-          <a:noFill/>
-          <a:ln/>
-        </p:spPr>
-        <p:txBody>
-          <a:bodyPr wrap="square" lIns="0" tIns="0" rIns="0" bIns="0" rtlCol="0" anchor="ctr"/>
-          <a:lstStyle/>
-          <a:p>
-            <a:pPr indent="0" marL="0">
-              <a:buNone/>
-            </a:pPr>
-            <a:r>
-              <a:rPr lang="en-US" sz="1300" dirty="0">
-                <a:solidFill>
-                  <a:srgbClr val="7B8A9C"/>
-                </a:solidFill>
-                <a:latin typeface="Calibri" pitchFamily="34" charset="0"/>
-                <a:ea typeface="Calibri" pitchFamily="34" charset="-122"/>
-                <a:cs typeface="Calibri" pitchFamily="34" charset="-120"/>
-              </a:rPr>
-              <a:t>what an interactive flow sees</a:t>
+            <a:endParaRPr lang="en-US" sz="1400" dirty="0"/>
+          </a:p>
+        </p:txBody>
+      </p:sp>
+      <p:sp>
+        <p:nvSpPr>
+          <p:cNvPr id="22" name="Text 20"/>
+          <p:cNvSpPr txBox="1"/>
+          <p:nvPr/>
+        </p:nvSpPr>
+        <p:spPr>
+          <a:xfrm>
+            <a:off x="7498080" y="3483864"/>
+            <a:ext cx="1828800" cy="329184"/>
+          </a:xfrm>
+          <a:prstGeom prst="rect">
+            <a:avLst/>
+          </a:prstGeom>
+          <a:noFill/>
+          <a:ln/>
+        </p:spPr>
+        <p:txBody>
+          <a:bodyPr wrap="square" lIns="0" tIns="0" rIns="0" bIns="0" rtlCol="0" anchor="ctr"/>
+          <a:lstStyle/>
+          <a:p>
+            <a:pPr indent="0" marL="0">
+              <a:buNone/>
+            </a:pPr>
+            <a:r>
+              <a:rPr lang="en-US" sz="1400" b="1" dirty="0">
+                <a:solidFill>
+                  <a:srgbClr val="3A4A5F"/>
+                </a:solidFill>
+                <a:latin typeface="Cambria" pitchFamily="34" charset="0"/>
+                <a:ea typeface="Cambria" pitchFamily="34" charset="-122"/>
+                <a:cs typeface="Cambria" pitchFamily="34" charset="-120"/>
+              </a:rPr>
+              <a:t>36.4 ms</a:t>
+            </a:r>
+            <a:endParaRPr lang="en-US" sz="1400" dirty="0"/>
+          </a:p>
+        </p:txBody>
+      </p:sp>
+      <p:sp>
+        <p:nvSpPr>
+          <p:cNvPr id="23" name="Text 21"/>
+          <p:cNvSpPr txBox="1"/>
+          <p:nvPr/>
+        </p:nvSpPr>
+        <p:spPr>
+          <a:xfrm>
+            <a:off x="9601200" y="3502152"/>
+            <a:ext cx="1463040" cy="292608"/>
+          </a:xfrm>
+          <a:prstGeom prst="rect">
+            <a:avLst/>
+          </a:prstGeom>
+          <a:noFill/>
+          <a:ln/>
+        </p:spPr>
+        <p:txBody>
+          <a:bodyPr wrap="square" lIns="0" tIns="0" rIns="0" bIns="0" rtlCol="0" anchor="ctr"/>
+          <a:lstStyle/>
+          <a:p>
+            <a:pPr indent="0" marL="0">
+              <a:buNone/>
+            </a:pPr>
+            <a:r>
+              <a:rPr lang="en-US" sz="1300" b="1" dirty="0">
+                <a:solidFill>
+                  <a:srgbClr val="3A4A5F"/>
+                </a:solidFill>
+                <a:latin typeface="Calibri" pitchFamily="34" charset="0"/>
+                <a:ea typeface="Calibri" pitchFamily="34" charset="-122"/>
+                <a:cs typeface="Calibri" pitchFamily="34" charset="-120"/>
+              </a:rPr>
+              <a:t>1.6x</a:t>
             </a:r>
             <a:endParaRPr lang="en-US" sz="1300" dirty="0"/>
           </a:p>
@@ -9544,64 +10098,240 @@
       </p:sp>
       <p:sp>
         <p:nvSpPr>
-          <p:cNvPr id="9" name="Shape 7"/>
+          <p:cNvPr id="24" name="Shape 22"/>
           <p:cNvSpPr/>
           <p:nvPr/>
         </p:nvSpPr>
         <p:spPr>
           <a:xfrm>
-            <a:off x="640080" y="3474720"/>
-            <a:ext cx="10881360" cy="960120"/>
+            <a:off x="640080" y="3950208"/>
+            <a:ext cx="10881360" cy="475488"/>
           </a:xfrm>
           <a:prstGeom prst="roundRect">
             <a:avLst>
-              <a:gd name="adj" fmla="val 7619"/>
+              <a:gd name="adj" fmla="val 9615"/>
+            </a:avLst>
+          </a:prstGeom>
+          <a:solidFill>
+            <a:srgbClr val="F6FAFC"/>
+          </a:solidFill>
+          <a:ln w="6350">
+            <a:solidFill>
+              <a:srgbClr val="E2ECF2"/>
+            </a:solidFill>
+            <a:prstDash val="solid"/>
+          </a:ln>
+        </p:spPr>
+      </p:sp>
+      <p:sp>
+        <p:nvSpPr>
+          <p:cNvPr id="25" name="Text 23"/>
+          <p:cNvSpPr txBox="1"/>
+          <p:nvPr/>
+        </p:nvSpPr>
+        <p:spPr>
+          <a:xfrm>
+            <a:off x="914400" y="4050792"/>
+            <a:ext cx="4480560" cy="292608"/>
+          </a:xfrm>
+          <a:prstGeom prst="rect">
+            <a:avLst/>
+          </a:prstGeom>
+          <a:noFill/>
+          <a:ln/>
+        </p:spPr>
+        <p:txBody>
+          <a:bodyPr wrap="square" lIns="0" tIns="0" rIns="0" bIns="0" rtlCol="0" anchor="ctr"/>
+          <a:lstStyle/>
+          <a:p>
+            <a:pPr indent="0" marL="0">
+              <a:buNone/>
+            </a:pPr>
+            <a:r>
+              <a:rPr lang="en-US" sz="1300" dirty="0">
+                <a:solidFill>
+                  <a:srgbClr val="13233B"/>
+                </a:solidFill>
+                <a:latin typeface="Calibri" pitchFamily="34" charset="0"/>
+                <a:ea typeface="Calibri" pitchFamily="34" charset="-122"/>
+                <a:cs typeface="Calibri" pitchFamily="34" charset="-120"/>
+              </a:rPr>
+              <a:t>CAKE</a:t>
+            </a:r>
+            <a:endParaRPr lang="en-US" sz="1300" dirty="0"/>
+          </a:p>
+        </p:txBody>
+      </p:sp>
+      <p:sp>
+        <p:nvSpPr>
+          <p:cNvPr id="26" name="Text 24"/>
+          <p:cNvSpPr txBox="1"/>
+          <p:nvPr/>
+        </p:nvSpPr>
+        <p:spPr>
+          <a:xfrm>
+            <a:off x="5486400" y="4032504"/>
+            <a:ext cx="1828800" cy="329184"/>
+          </a:xfrm>
+          <a:prstGeom prst="rect">
+            <a:avLst/>
+          </a:prstGeom>
+          <a:noFill/>
+          <a:ln/>
+        </p:spPr>
+        <p:txBody>
+          <a:bodyPr wrap="square" lIns="0" tIns="0" rIns="0" bIns="0" rtlCol="0" anchor="ctr"/>
+          <a:lstStyle/>
+          <a:p>
+            <a:pPr indent="0" marL="0">
+              <a:buNone/>
+            </a:pPr>
+            <a:r>
+              <a:rPr lang="en-US" sz="1400" dirty="0">
+                <a:solidFill>
+                  <a:srgbClr val="1C7293"/>
+                </a:solidFill>
+                <a:latin typeface="Cambria" pitchFamily="34" charset="0"/>
+                <a:ea typeface="Cambria" pitchFamily="34" charset="-122"/>
+                <a:cs typeface="Cambria" pitchFamily="34" charset="-120"/>
+              </a:rPr>
+              <a:t>21.8 ms</a:t>
+            </a:r>
+            <a:endParaRPr lang="en-US" sz="1400" dirty="0"/>
+          </a:p>
+        </p:txBody>
+      </p:sp>
+      <p:sp>
+        <p:nvSpPr>
+          <p:cNvPr id="27" name="Text 25"/>
+          <p:cNvSpPr txBox="1"/>
+          <p:nvPr/>
+        </p:nvSpPr>
+        <p:spPr>
+          <a:xfrm>
+            <a:off x="7498080" y="4032504"/>
+            <a:ext cx="1828800" cy="329184"/>
+          </a:xfrm>
+          <a:prstGeom prst="rect">
+            <a:avLst/>
+          </a:prstGeom>
+          <a:noFill/>
+          <a:ln/>
+        </p:spPr>
+        <p:txBody>
+          <a:bodyPr wrap="square" lIns="0" tIns="0" rIns="0" bIns="0" rtlCol="0" anchor="ctr"/>
+          <a:lstStyle/>
+          <a:p>
+            <a:pPr indent="0" marL="0">
+              <a:buNone/>
+            </a:pPr>
+            <a:r>
+              <a:rPr lang="en-US" sz="1400" b="1" dirty="0">
+                <a:solidFill>
+                  <a:srgbClr val="3A4A5F"/>
+                </a:solidFill>
+                <a:latin typeface="Cambria" pitchFamily="34" charset="0"/>
+                <a:ea typeface="Cambria" pitchFamily="34" charset="-122"/>
+                <a:cs typeface="Cambria" pitchFamily="34" charset="-120"/>
+              </a:rPr>
+              <a:t>33.6 ms</a:t>
+            </a:r>
+            <a:endParaRPr lang="en-US" sz="1400" dirty="0"/>
+          </a:p>
+        </p:txBody>
+      </p:sp>
+      <p:sp>
+        <p:nvSpPr>
+          <p:cNvPr id="28" name="Text 26"/>
+          <p:cNvSpPr txBox="1"/>
+          <p:nvPr/>
+        </p:nvSpPr>
+        <p:spPr>
+          <a:xfrm>
+            <a:off x="9601200" y="4050792"/>
+            <a:ext cx="1463040" cy="292608"/>
+          </a:xfrm>
+          <a:prstGeom prst="rect">
+            <a:avLst/>
+          </a:prstGeom>
+          <a:noFill/>
+          <a:ln/>
+        </p:spPr>
+        <p:txBody>
+          <a:bodyPr wrap="square" lIns="0" tIns="0" rIns="0" bIns="0" rtlCol="0" anchor="ctr"/>
+          <a:lstStyle/>
+          <a:p>
+            <a:pPr indent="0" marL="0">
+              <a:buNone/>
+            </a:pPr>
+            <a:r>
+              <a:rPr lang="en-US" sz="1300" b="1" dirty="0">
+                <a:solidFill>
+                  <a:srgbClr val="3A4A5F"/>
+                </a:solidFill>
+                <a:latin typeface="Calibri" pitchFamily="34" charset="0"/>
+                <a:ea typeface="Calibri" pitchFamily="34" charset="-122"/>
+                <a:cs typeface="Calibri" pitchFamily="34" charset="-120"/>
+              </a:rPr>
+              <a:t>1.5x</a:t>
+            </a:r>
+            <a:endParaRPr lang="en-US" sz="1300" dirty="0"/>
+          </a:p>
+        </p:txBody>
+      </p:sp>
+      <p:sp>
+        <p:nvSpPr>
+          <p:cNvPr id="29" name="Shape 27"/>
+          <p:cNvSpPr/>
+          <p:nvPr/>
+        </p:nvSpPr>
+        <p:spPr>
+          <a:xfrm>
+            <a:off x="640080" y="4498848"/>
+            <a:ext cx="10881360" cy="475488"/>
+          </a:xfrm>
+          <a:prstGeom prst="roundRect">
+            <a:avLst>
+              <a:gd name="adj" fmla="val 9615"/>
             </a:avLst>
           </a:prstGeom>
           <a:solidFill>
             <a:srgbClr val="EEF4F8"/>
           </a:solidFill>
-          <a:ln w="9525">
+          <a:ln w="6350">
             <a:solidFill>
-              <a:srgbClr val="D8E4EC"/>
+              <a:srgbClr val="E2ECF2"/>
             </a:solidFill>
             <a:prstDash val="solid"/>
           </a:ln>
-          <a:effectLst>
-            <a:outerShdw sx="100000" sy="100000" kx="0" ky="0" algn="bl" rotWithShape="0" blurRad="50800" dist="12700" dir="5400000">
-              <a:srgbClr val="BFCEDA">
-                <a:alpha val="35000"/>
-              </a:srgbClr>
-            </a:outerShdw>
-          </a:effectLst>
-        </p:spPr>
-      </p:sp>
-      <p:sp>
-        <p:nvSpPr>
-          <p:cNvPr id="10" name="Text 8"/>
-          <p:cNvSpPr txBox="1"/>
-          <p:nvPr/>
-        </p:nvSpPr>
-        <p:spPr>
-          <a:xfrm>
-            <a:off x="960120" y="3584448"/>
-            <a:ext cx="3291840" cy="365760"/>
-          </a:xfrm>
-          <a:prstGeom prst="rect">
-            <a:avLst/>
-          </a:prstGeom>
-          <a:noFill/>
-          <a:ln/>
-        </p:spPr>
-        <p:txBody>
-          <a:bodyPr wrap="square" lIns="0" tIns="0" rIns="0" bIns="0" rtlCol="0" anchor="ctr"/>
-          <a:lstStyle/>
-          <a:p>
-            <a:pPr indent="0" marL="0">
-              <a:buNone/>
-            </a:pPr>
-            <a:r>
-              <a:rPr lang="en-US" sz="1500" b="1" dirty="0">
+        </p:spPr>
+      </p:sp>
+      <p:sp>
+        <p:nvSpPr>
+          <p:cNvPr id="30" name="Text 28"/>
+          <p:cNvSpPr txBox="1"/>
+          <p:nvPr/>
+        </p:nvSpPr>
+        <p:spPr>
+          <a:xfrm>
+            <a:off x="914400" y="4599432"/>
+            <a:ext cx="4480560" cy="292608"/>
+          </a:xfrm>
+          <a:prstGeom prst="rect">
+            <a:avLst/>
+          </a:prstGeom>
+          <a:noFill/>
+          <a:ln/>
+        </p:spPr>
+        <p:txBody>
+          <a:bodyPr wrap="square" lIns="0" tIns="0" rIns="0" bIns="0" rtlCol="0" anchor="ctr"/>
+          <a:lstStyle/>
+          <a:p>
+            <a:pPr indent="0" marL="0">
+              <a:buNone/>
+            </a:pPr>
+            <a:r>
+              <a:rPr lang="en-US" sz="1300" dirty="0">
                 <a:solidFill>
                   <a:srgbClr val="13233B"/>
                 </a:solidFill>
@@ -9609,85 +10339,124 @@
                 <a:ea typeface="Calibri" pitchFamily="34" charset="-122"/>
                 <a:cs typeface="Calibri" pitchFamily="34" charset="-120"/>
               </a:rPr>
-              <a:t>Bulk TCP flows</a:t>
-            </a:r>
-            <a:endParaRPr lang="en-US" sz="1500" dirty="0"/>
-          </a:p>
-        </p:txBody>
-      </p:sp>
-      <p:sp>
-        <p:nvSpPr>
-          <p:cNvPr id="11" name="Text 9"/>
-          <p:cNvSpPr txBox="1"/>
-          <p:nvPr/>
-        </p:nvSpPr>
-        <p:spPr>
-          <a:xfrm>
-            <a:off x="4389120" y="3566160"/>
-            <a:ext cx="1828800" cy="548640"/>
-          </a:xfrm>
-          <a:prstGeom prst="rect">
-            <a:avLst/>
-          </a:prstGeom>
-          <a:noFill/>
-          <a:ln/>
-        </p:spPr>
-        <p:txBody>
-          <a:bodyPr wrap="square" lIns="0" tIns="0" rIns="0" bIns="0" rtlCol="0" anchor="ctr"/>
-          <a:lstStyle/>
-          <a:p>
-            <a:pPr indent="0" marL="0">
-              <a:buNone/>
-            </a:pPr>
-            <a:r>
-              <a:rPr lang="en-US" sz="2800" b="1" dirty="0">
-                <a:solidFill>
-                  <a:srgbClr val="065A82"/>
+              <a:t>CoDel  (single queue)</a:t>
+            </a:r>
+            <a:endParaRPr lang="en-US" sz="1300" dirty="0"/>
+          </a:p>
+        </p:txBody>
+      </p:sp>
+      <p:sp>
+        <p:nvSpPr>
+          <p:cNvPr id="31" name="Text 29"/>
+          <p:cNvSpPr txBox="1"/>
+          <p:nvPr/>
+        </p:nvSpPr>
+        <p:spPr>
+          <a:xfrm>
+            <a:off x="5486400" y="4581144"/>
+            <a:ext cx="1828800" cy="329184"/>
+          </a:xfrm>
+          <a:prstGeom prst="rect">
+            <a:avLst/>
+          </a:prstGeom>
+          <a:noFill/>
+          <a:ln/>
+        </p:spPr>
+        <p:txBody>
+          <a:bodyPr wrap="square" lIns="0" tIns="0" rIns="0" bIns="0" rtlCol="0" anchor="ctr"/>
+          <a:lstStyle/>
+          <a:p>
+            <a:pPr indent="0" marL="0">
+              <a:buNone/>
+            </a:pPr>
+            <a:r>
+              <a:rPr lang="en-US" sz="1400" dirty="0">
+                <a:solidFill>
+                  <a:srgbClr val="1C7293"/>
                 </a:solidFill>
                 <a:latin typeface="Cambria" pitchFamily="34" charset="0"/>
                 <a:ea typeface="Cambria" pitchFamily="34" charset="-122"/>
                 <a:cs typeface="Cambria" pitchFamily="34" charset="-120"/>
               </a:rPr>
-              <a:t>36.3 ms</a:t>
-            </a:r>
-            <a:endParaRPr lang="en-US" sz="2800" dirty="0"/>
-          </a:p>
-        </p:txBody>
-      </p:sp>
-      <p:sp>
-        <p:nvSpPr>
-          <p:cNvPr id="12" name="Text 10"/>
-          <p:cNvSpPr txBox="1"/>
-          <p:nvPr/>
-        </p:nvSpPr>
-        <p:spPr>
-          <a:xfrm>
-            <a:off x="6400800" y="3703320"/>
-            <a:ext cx="4754880" cy="365760"/>
-          </a:xfrm>
-          <a:prstGeom prst="rect">
-            <a:avLst/>
-          </a:prstGeom>
-          <a:noFill/>
-          <a:ln/>
-        </p:spPr>
-        <p:txBody>
-          <a:bodyPr wrap="square" lIns="0" tIns="0" rIns="0" bIns="0" rtlCol="0" anchor="ctr"/>
-          <a:lstStyle/>
-          <a:p>
-            <a:pPr indent="0" marL="0">
-              <a:buNone/>
-            </a:pPr>
-            <a:r>
-              <a:rPr lang="en-US" sz="1300" dirty="0">
-                <a:solidFill>
-                  <a:srgbClr val="7B8A9C"/>
-                </a:solidFill>
-                <a:latin typeface="Calibri" pitchFamily="34" charset="0"/>
-                <a:ea typeface="Calibri" pitchFamily="34" charset="-122"/>
-                <a:cs typeface="Calibri" pitchFamily="34" charset="-120"/>
-              </a:rPr>
-              <a:t>what the data flows actually see</a:t>
+              <a:t>39.2 ms</a:t>
+            </a:r>
+            <a:endParaRPr lang="en-US" sz="1400" dirty="0"/>
+          </a:p>
+        </p:txBody>
+      </p:sp>
+      <p:sp>
+        <p:nvSpPr>
+          <p:cNvPr id="32" name="Text 30"/>
+          <p:cNvSpPr txBox="1"/>
+          <p:nvPr/>
+        </p:nvSpPr>
+        <p:spPr>
+          <a:xfrm>
+            <a:off x="7498080" y="4581144"/>
+            <a:ext cx="1828800" cy="329184"/>
+          </a:xfrm>
+          <a:prstGeom prst="rect">
+            <a:avLst/>
+          </a:prstGeom>
+          <a:noFill/>
+          <a:ln/>
+        </p:spPr>
+        <p:txBody>
+          <a:bodyPr wrap="square" lIns="0" tIns="0" rIns="0" bIns="0" rtlCol="0" anchor="ctr"/>
+          <a:lstStyle/>
+          <a:p>
+            <a:pPr indent="0" marL="0">
+              <a:buNone/>
+            </a:pPr>
+            <a:r>
+              <a:rPr lang="en-US" sz="1400" b="1" dirty="0">
+                <a:solidFill>
+                  <a:srgbClr val="2C7A5A"/>
+                </a:solidFill>
+                <a:latin typeface="Cambria" pitchFamily="34" charset="0"/>
+                <a:ea typeface="Cambria" pitchFamily="34" charset="-122"/>
+                <a:cs typeface="Cambria" pitchFamily="34" charset="-120"/>
+              </a:rPr>
+              <a:t>44.4 ms</a:t>
+            </a:r>
+            <a:endParaRPr lang="en-US" sz="1400" dirty="0"/>
+          </a:p>
+        </p:txBody>
+      </p:sp>
+      <p:sp>
+        <p:nvSpPr>
+          <p:cNvPr id="33" name="Text 31"/>
+          <p:cNvSpPr txBox="1"/>
+          <p:nvPr/>
+        </p:nvSpPr>
+        <p:spPr>
+          <a:xfrm>
+            <a:off x="9601200" y="4599432"/>
+            <a:ext cx="1463040" cy="292608"/>
+          </a:xfrm>
+          <a:prstGeom prst="rect">
+            <a:avLst/>
+          </a:prstGeom>
+          <a:noFill/>
+          <a:ln/>
+        </p:spPr>
+        <p:txBody>
+          <a:bodyPr wrap="square" lIns="0" tIns="0" rIns="0" bIns="0" rtlCol="0" anchor="ctr"/>
+          <a:lstStyle/>
+          <a:p>
+            <a:pPr indent="0" marL="0">
+              <a:buNone/>
+            </a:pPr>
+            <a:r>
+              <a:rPr lang="en-US" sz="1300" b="1" dirty="0">
+                <a:solidFill>
+                  <a:srgbClr val="2C7A5A"/>
+                </a:solidFill>
+                <a:latin typeface="Calibri" pitchFamily="34" charset="0"/>
+                <a:ea typeface="Calibri" pitchFamily="34" charset="-122"/>
+                <a:cs typeface="Calibri" pitchFamily="34" charset="-120"/>
+              </a:rPr>
+              <a:t>1.1x</a:t>
             </a:r>
             <a:endParaRPr lang="en-US" sz="1300" dirty="0"/>
           </a:p>
@@ -9695,18 +10464,18 @@
       </p:sp>
       <p:sp>
         <p:nvSpPr>
-          <p:cNvPr id="13" name="Shape 11"/>
+          <p:cNvPr id="34" name="Shape 32"/>
           <p:cNvSpPr/>
           <p:nvPr/>
         </p:nvSpPr>
         <p:spPr>
           <a:xfrm>
-            <a:off x="640080" y="4709160"/>
-            <a:ext cx="10881360" cy="914400"/>
+            <a:off x="640080" y="5166360"/>
+            <a:ext cx="10881360" cy="1143000"/>
           </a:xfrm>
           <a:prstGeom prst="roundRect">
             <a:avLst>
-              <a:gd name="adj" fmla="val 8000"/>
+              <a:gd name="adj" fmla="val 6400"/>
             </a:avLst>
           </a:prstGeom>
           <a:solidFill>
@@ -9729,40 +10498,79 @@
       </p:sp>
       <p:sp>
         <p:nvSpPr>
-          <p:cNvPr id="14" name="Text 12"/>
-          <p:cNvSpPr txBox="1"/>
-          <p:nvPr/>
-        </p:nvSpPr>
-        <p:spPr>
-          <a:xfrm>
-            <a:off x="960120" y="4892040"/>
-            <a:ext cx="10241280" cy="548640"/>
-          </a:xfrm>
-          <a:prstGeom prst="rect">
-            <a:avLst/>
-          </a:prstGeom>
-          <a:noFill/>
-          <a:ln/>
-        </p:spPr>
-        <p:txBody>
-          <a:bodyPr wrap="square" lIns="0" tIns="0" rIns="0" bIns="0" rtlCol="0" anchor="ctr"/>
-          <a:lstStyle/>
-          <a:p>
-            <a:pPr indent="0" marL="0">
-              <a:buNone/>
-            </a:pPr>
-            <a:r>
-              <a:rPr lang="en-US" sz="1500" dirty="0">
+          <p:cNvPr id="35" name="Text 33"/>
+          <p:cNvSpPr txBox="1"/>
+          <p:nvPr/>
+        </p:nvSpPr>
+        <p:spPr>
+          <a:xfrm>
+            <a:off x="960120" y="5321808"/>
+            <a:ext cx="10241280" cy="347472"/>
+          </a:xfrm>
+          <a:prstGeom prst="rect">
+            <a:avLst/>
+          </a:prstGeom>
+          <a:noFill/>
+          <a:ln/>
+        </p:spPr>
+        <p:txBody>
+          <a:bodyPr wrap="square" lIns="0" tIns="0" rIns="0" bIns="0" rtlCol="0" anchor="ctr"/>
+          <a:lstStyle/>
+          <a:p>
+            <a:pPr indent="0" marL="0">
+              <a:buNone/>
+            </a:pPr>
+            <a:r>
+              <a:rPr lang="en-US" sz="1700" b="1" dirty="0">
                 <a:solidFill>
                   <a:srgbClr val="065A82"/>
                 </a:solidFill>
-                <a:latin typeface="Calibri" pitchFamily="34" charset="0"/>
-                <a:ea typeface="Calibri" pitchFamily="34" charset="-122"/>
-                <a:cs typeface="Calibri" pitchFamily="34" charset="-120"/>
-              </a:rPr>
-              <a:t>A 62% difference. Quoting only the probe — as the original work did — overstates the benefit to bulk traffic. Both belong in a latency claim.</a:t>
-            </a:r>
-            <a:endParaRPr lang="en-US" sz="1500" dirty="0"/>
+                <a:latin typeface="Cambria" pitchFamily="34" charset="0"/>
+                <a:ea typeface="Cambria" pitchFamily="34" charset="-122"/>
+                <a:cs typeface="Cambria" pitchFamily="34" charset="-120"/>
+              </a:rPr>
+              <a:t>Quoting only the probe inverts the ranking.</a:t>
+            </a:r>
+            <a:endParaRPr lang="en-US" sz="1700" dirty="0"/>
+          </a:p>
+        </p:txBody>
+      </p:sp>
+      <p:sp>
+        <p:nvSpPr>
+          <p:cNvPr id="36" name="Text 34"/>
+          <p:cNvSpPr txBox="1"/>
+          <p:nvPr/>
+        </p:nvSpPr>
+        <p:spPr>
+          <a:xfrm>
+            <a:off x="960120" y="5669280"/>
+            <a:ext cx="10241280" cy="594360"/>
+          </a:xfrm>
+          <a:prstGeom prst="rect">
+            <a:avLst/>
+          </a:prstGeom>
+          <a:noFill/>
+          <a:ln/>
+        </p:spPr>
+        <p:txBody>
+          <a:bodyPr wrap="square" lIns="0" tIns="0" rIns="0" bIns="0" rtlCol="0" anchor="ctr"/>
+          <a:lstStyle/>
+          <a:p>
+            <a:pPr indent="0" marL="0">
+              <a:buNone/>
+            </a:pPr>
+            <a:r>
+              <a:rPr lang="en-US" sz="1250" dirty="0">
+                <a:solidFill>
+                  <a:srgbClr val="3A4A5F"/>
+                </a:solidFill>
+                <a:latin typeface="Calibri" pitchFamily="34" charset="0"/>
+                <a:ea typeface="Calibri" pitchFamily="34" charset="-122"/>
+                <a:cs typeface="Calibri" pitchFamily="34" charset="-120"/>
+              </a:rPr>
+              <a:t>By probe RTT, SFQ (30.7 ms) beats CoDel (39.2 ms). By what the data flows actually experience, SFQ is 294 ms against CoDel's 44 ms — nearly 7x worse. SFQ gives the probe its own short queue but has no AQM, so the bulk queues sit at its 127-packet limit throughout.</a:t>
+            </a:r>
+            <a:endParaRPr lang="en-US" sz="1250" dirty="0"/>
           </a:p>
         </p:txBody>
       </p:sp>

</xml_diff>